<commit_message>
Add Super Admin panel parity, template positioning, and deploy setup
- Super Admin: full templates/batches/generator-admin management mirroring
  Org Admin, with delete-batch and add-more-candidates support
- Certificate templates: DOB/Enrolment No fields, optional QR/signature
  overlays, background-size-aware position scaling on upload
- Public /verify landing page for manual Certificate No lookup, alongside
  the existing QR-code verification flow
- Switch file storage from Cloudinary to local disk (lib/storage.ts)
- Add Dockerfile/.dockerignore for Dokploy/VPS deployment

Co-Authored-By: Claude Sonnet 5 <noreply@anthropic.com>
</commit_message>
<xml_diff>
--- a/templates/samples/GD_Goenka_Certificate_Editable.pptx
+++ b/templates/samples/GD_Goenka_Certificate_Editable.pptx
@@ -918,7 +918,7 @@
         </p:nvSpPr>
         <p:spPr>
           <a:xfrm>
-            <a:off x="7360920" y="365760"/>
+            <a:off x="7404509" y="357194"/>
             <a:ext cx="1234440" cy="1417320"/>
           </a:xfrm>
           <a:prstGeom prst="rect">
@@ -987,7 +987,7 @@
         </p:nvSpPr>
         <p:spPr>
           <a:xfrm>
-            <a:off x="7479437" y="1840083"/>
+            <a:off x="7277001" y="1821661"/>
             <a:ext cx="997406" cy="211453"/>
           </a:xfrm>
           <a:prstGeom prst="rect">
@@ -1048,7 +1048,7 @@
         </p:nvSpPr>
         <p:spPr>
           <a:xfrm>
-            <a:off x="7132320" y="2234241"/>
+            <a:off x="6903720" y="2234241"/>
             <a:ext cx="1737360" cy="0"/>
           </a:xfrm>
           <a:prstGeom prst="line">
@@ -1139,8 +1139,8 @@
         </p:nvSpPr>
         <p:spPr>
           <a:xfrm>
-            <a:off x="2606040" y="2652917"/>
-            <a:ext cx="4617720" cy="0"/>
+            <a:off x="2606040" y="2652916"/>
+            <a:ext cx="6035040" cy="10461"/>
           </a:xfrm>
           <a:prstGeom prst="line">
             <a:avLst/>
@@ -1721,36 +1721,13 @@
       </p:sp>
       <p:sp>
         <p:nvSpPr>
-          <p:cNvPr id="43" name="Shape 41"/>
-          <p:cNvSpPr/>
-          <p:nvPr/>
-        </p:nvSpPr>
-        <p:spPr>
-          <a:xfrm>
-            <a:off x="7223760" y="4034637"/>
-            <a:ext cx="1417320" cy="0"/>
-          </a:xfrm>
-          <a:prstGeom prst="line">
-            <a:avLst/>
-          </a:prstGeom>
-          <a:noFill/>
-          <a:ln w="9525">
-            <a:solidFill>
-              <a:srgbClr val="222222"/>
-            </a:solidFill>
-            <a:prstDash val="solid"/>
-          </a:ln>
-        </p:spPr>
-      </p:sp>
-      <p:sp>
-        <p:nvSpPr>
           <p:cNvPr id="44" name="Text 42"/>
           <p:cNvSpPr/>
           <p:nvPr/>
         </p:nvSpPr>
         <p:spPr>
           <a:xfrm>
-            <a:off x="502920" y="4362633"/>
+            <a:off x="466344" y="4293893"/>
             <a:ext cx="1188720" cy="240121"/>
           </a:xfrm>
           <a:prstGeom prst="rect">
@@ -1811,7 +1788,7 @@
         </p:nvSpPr>
         <p:spPr>
           <a:xfrm>
-            <a:off x="1463040" y="4553712"/>
+            <a:off x="1426464" y="4484972"/>
             <a:ext cx="2148840" cy="0"/>
           </a:xfrm>
           <a:prstGeom prst="line">
@@ -1882,42 +1859,6 @@
               <a:t>Program Director</a:t>
             </a:r>
             <a:endParaRPr lang="en-US" sz="1051" dirty="0"/>
-          </a:p>
-        </p:txBody>
-      </p:sp>
-      <p:sp>
-        <p:nvSpPr>
-          <p:cNvPr id="78" name="Text 76"/>
-          <p:cNvSpPr/>
-          <p:nvPr/>
-        </p:nvSpPr>
-        <p:spPr>
-          <a:xfrm>
-            <a:off x="297180" y="6190488"/>
-            <a:ext cx="1874520" cy="457200"/>
-          </a:xfrm>
-          <a:prstGeom prst="rect">
-            <a:avLst/>
-          </a:prstGeom>
-          <a:noFill/>
-          <a:ln/>
-        </p:spPr>
-        <p:txBody>
-          <a:bodyPr wrap="square" rtlCol="0" anchor="ctr"/>
-          <a:lstStyle/>
-          <a:p>
-            <a:r>
-              <a:rPr lang="en-US" sz="900" b="1" dirty="0">
-                <a:solidFill>
-                  <a:srgbClr val="8A8A8A"/>
-                </a:solidFill>
-                <a:latin typeface="Arial" pitchFamily="34" charset="0"/>
-                <a:ea typeface="Arial" pitchFamily="34" charset="-122"/>
-                <a:cs typeface="Arial" pitchFamily="34" charset="-120"/>
-              </a:rPr>
-              <a:t>Digitally verified Certificate</a:t>
-            </a:r>
-            <a:endParaRPr lang="en-US" sz="900" b="1" dirty="0"/>
           </a:p>
         </p:txBody>
       </p:sp>
@@ -1996,7 +1937,7 @@
         </p:blipFill>
         <p:spPr>
           <a:xfrm>
-            <a:off x="391858" y="4936426"/>
+            <a:off x="353410" y="5101019"/>
             <a:ext cx="1410843" cy="1410843"/>
           </a:xfrm>
           <a:prstGeom prst="rect">
@@ -2045,6 +1986,42 @@
           </a:ln>
         </p:spPr>
       </p:pic>
+      <p:sp>
+        <p:nvSpPr>
+          <p:cNvPr id="78" name="Text 76"/>
+          <p:cNvSpPr/>
+          <p:nvPr/>
+        </p:nvSpPr>
+        <p:spPr>
+          <a:xfrm>
+            <a:off x="297180" y="6194100"/>
+            <a:ext cx="1874520" cy="457200"/>
+          </a:xfrm>
+          <a:prstGeom prst="rect">
+            <a:avLst/>
+          </a:prstGeom>
+          <a:noFill/>
+          <a:ln/>
+        </p:spPr>
+        <p:txBody>
+          <a:bodyPr wrap="square" rtlCol="0" anchor="ctr"/>
+          <a:lstStyle/>
+          <a:p>
+            <a:r>
+              <a:rPr lang="en-US" sz="900" b="1" dirty="0">
+                <a:solidFill>
+                  <a:srgbClr val="8A8A8A"/>
+                </a:solidFill>
+                <a:latin typeface="Arial" pitchFamily="34" charset="0"/>
+                <a:ea typeface="Arial" pitchFamily="34" charset="-122"/>
+                <a:cs typeface="Arial" pitchFamily="34" charset="-120"/>
+              </a:rPr>
+              <a:t>Digitally verified Certificate</a:t>
+            </a:r>
+            <a:endParaRPr lang="en-US" sz="900" b="1" dirty="0"/>
+          </a:p>
+        </p:txBody>
+      </p:sp>
     </p:spTree>
   </p:cSld>
   <p:clrMapOvr>

</xml_diff>

<commit_message>
Fix S/O, D/O, W/O label overlap with father's name on certificates
The GD Goenka certificate template's parent-name label was changed from
"Son of" to "S/O, D/O, W/O" to cover daughters and married candidates,
but the longer label text now overlapped the FATHER_NAME value's default
x-position (calibrated for the shorter "Son of"). Shift the default
FATHER_NAME x from 135 to 160 so the value renders clear of the label,
and update the bundled sample template files to match.

Co-Authored-By: Claude Sonnet 5 <noreply@anthropic.com>
</commit_message>
<xml_diff>
--- a/templates/samples/GD_Goenka_Certificate_Editable.pptx
+++ b/templates/samples/GD_Goenka_Certificate_Editable.pptx
@@ -912,75 +912,6 @@
       </p:sp>
       <p:sp>
         <p:nvSpPr>
-          <p:cNvPr id="15" name="Shape 13"/>
-          <p:cNvSpPr/>
-          <p:nvPr/>
-        </p:nvSpPr>
-        <p:spPr>
-          <a:xfrm>
-            <a:off x="7404509" y="357194"/>
-            <a:ext cx="1234440" cy="1417320"/>
-          </a:xfrm>
-          <a:prstGeom prst="rect">
-            <a:avLst/>
-          </a:prstGeom>
-          <a:solidFill>
-            <a:srgbClr val="F5F5F5"/>
-          </a:solidFill>
-          <a:ln w="12700">
-            <a:solidFill>
-              <a:srgbClr val="222222"/>
-            </a:solidFill>
-            <a:prstDash val="solid"/>
-          </a:ln>
-        </p:spPr>
-        <p:txBody>
-          <a:bodyPr/>
-          <a:lstStyle/>
-          <a:p>
-            <a:endParaRPr lang="en-US" dirty="0"/>
-          </a:p>
-        </p:txBody>
-      </p:sp>
-      <p:sp>
-        <p:nvSpPr>
-          <p:cNvPr id="16" name="Text 14"/>
-          <p:cNvSpPr/>
-          <p:nvPr/>
-        </p:nvSpPr>
-        <p:spPr>
-          <a:xfrm>
-            <a:off x="7360920" y="365760"/>
-            <a:ext cx="1234440" cy="1417320"/>
-          </a:xfrm>
-          <a:prstGeom prst="rect">
-            <a:avLst/>
-          </a:prstGeom>
-          <a:noFill/>
-          <a:ln/>
-        </p:spPr>
-        <p:txBody>
-          <a:bodyPr wrap="square" rtlCol="0" anchor="ctr"/>
-          <a:lstStyle/>
-          <a:p>
-            <a:pPr algn="ctr"/>
-            <a:r>
-              <a:rPr lang="en-US" sz="1200" dirty="0">
-                <a:solidFill>
-                  <a:srgbClr val="8A8A8A"/>
-                </a:solidFill>
-                <a:latin typeface="Arial" pitchFamily="34" charset="0"/>
-                <a:ea typeface="Arial" pitchFamily="34" charset="-122"/>
-                <a:cs typeface="Arial" pitchFamily="34" charset="-120"/>
-              </a:rPr>
-              <a:t>Photo</a:t>
-            </a:r>
-            <a:endParaRPr lang="en-US" sz="1200" dirty="0"/>
-          </a:p>
-        </p:txBody>
-      </p:sp>
-      <p:sp>
-        <p:nvSpPr>
           <p:cNvPr id="17" name="Text 15"/>
           <p:cNvSpPr/>
           <p:nvPr/>
@@ -1162,8 +1093,8 @@
         </p:nvSpPr>
         <p:spPr>
           <a:xfrm>
-            <a:off x="502920" y="2872373"/>
-            <a:ext cx="731520" cy="237744"/>
+            <a:off x="502919" y="2890660"/>
+            <a:ext cx="1031141" cy="217421"/>
           </a:xfrm>
           <a:prstGeom prst="rect">
             <a:avLst/>
@@ -1184,7 +1115,7 @@
                 <a:ea typeface="Arial" pitchFamily="34" charset="-122"/>
                 <a:cs typeface="Arial" pitchFamily="34" charset="-120"/>
               </a:rPr>
-              <a:t>Son of</a:t>
+              <a:t>S/O, D/O, W/O</a:t>
             </a:r>
             <a:endParaRPr lang="en-US" sz="1100" dirty="0"/>
           </a:p>
@@ -1198,7 +1129,7 @@
         </p:nvSpPr>
         <p:spPr>
           <a:xfrm>
-            <a:off x="1234440" y="2872373"/>
+            <a:off x="1307592" y="2872373"/>
             <a:ext cx="2331720" cy="237744"/>
           </a:xfrm>
           <a:prstGeom prst="rect">
@@ -1222,9 +1153,9 @@
           <p:nvPr/>
         </p:nvSpPr>
         <p:spPr>
-          <a:xfrm>
-            <a:off x="1234440" y="3091829"/>
-            <a:ext cx="2331720" cy="0"/>
+          <a:xfrm flipV="1">
+            <a:off x="1536192" y="3091826"/>
+            <a:ext cx="2029968" cy="7828"/>
           </a:xfrm>
           <a:prstGeom prst="line">
             <a:avLst/>
@@ -1330,8 +1261,8 @@
         </p:nvSpPr>
         <p:spPr>
           <a:xfrm>
-            <a:off x="6080760" y="2872373"/>
-            <a:ext cx="1051560" cy="237744"/>
+            <a:off x="6080760" y="2872372"/>
+            <a:ext cx="883920" cy="251527"/>
           </a:xfrm>
           <a:prstGeom prst="rect">
             <a:avLst/>
@@ -1390,9 +1321,9 @@
           <p:nvPr/>
         </p:nvSpPr>
         <p:spPr>
-          <a:xfrm>
-            <a:off x="7018421" y="3091829"/>
-            <a:ext cx="1622659" cy="0"/>
+          <a:xfrm flipV="1">
+            <a:off x="6964681" y="3091828"/>
+            <a:ext cx="1676400" cy="7827"/>
           </a:xfrm>
           <a:prstGeom prst="line">
             <a:avLst/>
@@ -1430,7 +1361,7 @@
             <a:r>
               <a:rPr lang="en-US" sz="1100" dirty="0">
                 <a:solidFill>
-                  <a:srgbClr val="222222"/>
+                  <a:schemeClr val="accent1"/>
                 </a:solidFill>
                 <a:latin typeface="Arial" pitchFamily="34" charset="0"/>
                 <a:ea typeface="Arial" pitchFamily="34" charset="-122"/>
@@ -1438,7 +1369,11 @@
               </a:rPr>
               <a:t>has successfully cleared the assessment in the job role/qualification</a:t>
             </a:r>
-            <a:endParaRPr lang="en-US" sz="1100" dirty="0"/>
+            <a:endParaRPr lang="en-US" sz="1100" dirty="0">
+              <a:solidFill>
+                <a:schemeClr val="accent1"/>
+              </a:solidFill>
+            </a:endParaRPr>
           </a:p>
         </p:txBody>
       </p:sp>
@@ -1688,7 +1623,7 @@
                 <a:ea typeface="Arial" pitchFamily="34" charset="-122"/>
                 <a:cs typeface="Arial" pitchFamily="34" charset="-120"/>
               </a:rPr>
-              <a:t>%/Grade</a:t>
+              <a:t>Grade/%</a:t>
             </a:r>
             <a:endParaRPr lang="en-US" sz="1100" dirty="0"/>
           </a:p>
@@ -1911,42 +1846,6 @@
       </p:pic>
       <p:pic>
         <p:nvPicPr>
-          <p:cNvPr id="80" name="Picture 79">
-            <a:extLst>
-              <a:ext uri="{FF2B5EF4-FFF2-40B4-BE49-F238E27FC236}">
-                <a16:creationId xmlns:a16="http://schemas.microsoft.com/office/drawing/2014/main" id="{AD84BA4C-DB8A-4947-51E4-A3C48CB48EDC}"/>
-              </a:ext>
-            </a:extLst>
-          </p:cNvPr>
-          <p:cNvPicPr>
-            <a:picLocks noChangeAspect="1"/>
-          </p:cNvPicPr>
-          <p:nvPr/>
-        </p:nvPicPr>
-        <p:blipFill>
-          <a:blip r:embed="rId4">
-            <a:extLst>
-              <a:ext uri="{837473B0-CC2E-450A-ABE3-18F120FF3D39}">
-                <a1611:picAttrSrcUrl xmlns:a1611="http://schemas.microsoft.com/office/drawing/2016/11/main" r:id="rId5"/>
-              </a:ext>
-            </a:extLst>
-          </a:blip>
-          <a:stretch>
-            <a:fillRect/>
-          </a:stretch>
-        </p:blipFill>
-        <p:spPr>
-          <a:xfrm>
-            <a:off x="353410" y="5101019"/>
-            <a:ext cx="1410843" cy="1410843"/>
-          </a:xfrm>
-          <a:prstGeom prst="rect">
-            <a:avLst/>
-          </a:prstGeom>
-        </p:spPr>
-      </p:pic>
-      <p:pic>
-        <p:nvPicPr>
           <p:cNvPr id="81" name="Picture 80">
             <a:extLst>
               <a:ext uri="{FF2B5EF4-FFF2-40B4-BE49-F238E27FC236}">
@@ -1960,7 +1859,7 @@
           <p:nvPr/>
         </p:nvPicPr>
         <p:blipFill>
-          <a:blip r:embed="rId6">
+          <a:blip r:embed="rId4">
             <a:extLst>
               <a:ext uri="{28A0092B-C50C-407E-A947-70E740481C1C}">
                 <a14:useLocalDpi xmlns:a14="http://schemas.microsoft.com/office/drawing/2010/main" val="0"/>
@@ -1974,7 +1873,7 @@
         </p:blipFill>
         <p:spPr bwMode="auto">
           <a:xfrm>
-            <a:off x="6554303" y="6139959"/>
+            <a:off x="6610712" y="6102422"/>
             <a:ext cx="1671601" cy="387254"/>
           </a:xfrm>
           <a:prstGeom prst="rect">
@@ -2022,6 +1921,66 @@
           </a:p>
         </p:txBody>
       </p:sp>
+      <p:pic>
+        <p:nvPicPr>
+          <p:cNvPr id="5" name="Picture 4">
+            <a:extLst>
+              <a:ext uri="{FF2B5EF4-FFF2-40B4-BE49-F238E27FC236}">
+                <a16:creationId xmlns:a16="http://schemas.microsoft.com/office/drawing/2014/main" id="{360BFFFB-5F4B-6304-7DFB-DCE7AC8C051A}"/>
+              </a:ext>
+            </a:extLst>
+          </p:cNvPr>
+          <p:cNvPicPr>
+            <a:picLocks noChangeAspect="1"/>
+          </p:cNvPicPr>
+          <p:nvPr/>
+        </p:nvPicPr>
+        <p:blipFill>
+          <a:blip r:embed="rId5"/>
+          <a:stretch>
+            <a:fillRect/>
+          </a:stretch>
+        </p:blipFill>
+        <p:spPr>
+          <a:xfrm rot="16200000">
+            <a:off x="6877937" y="4641369"/>
+            <a:ext cx="1048579" cy="1572869"/>
+          </a:xfrm>
+          <a:prstGeom prst="rect">
+            <a:avLst/>
+          </a:prstGeom>
+        </p:spPr>
+      </p:pic>
+      <p:pic>
+        <p:nvPicPr>
+          <p:cNvPr id="9" name="Picture 8">
+            <a:extLst>
+              <a:ext uri="{FF2B5EF4-FFF2-40B4-BE49-F238E27FC236}">
+                <a16:creationId xmlns:a16="http://schemas.microsoft.com/office/drawing/2014/main" id="{71498BF2-2EF5-BB5E-2416-6EE2ABB4A721}"/>
+              </a:ext>
+            </a:extLst>
+          </p:cNvPr>
+          <p:cNvPicPr>
+            <a:picLocks noChangeAspect="1"/>
+          </p:cNvPicPr>
+          <p:nvPr/>
+        </p:nvPicPr>
+        <p:blipFill>
+          <a:blip r:embed="rId6"/>
+          <a:stretch>
+            <a:fillRect/>
+          </a:stretch>
+        </p:blipFill>
+        <p:spPr>
+          <a:xfrm>
+            <a:off x="371666" y="4892745"/>
+            <a:ext cx="1488966" cy="1488966"/>
+          </a:xfrm>
+          <a:prstGeom prst="rect">
+            <a:avLst/>
+          </a:prstGeom>
+        </p:spPr>
+      </p:pic>
     </p:spTree>
   </p:cSld>
   <p:clrMapOvr>

</xml_diff>